<commit_message>
modified README and slides
</commit_message>
<xml_diff>
--- a/The_2nd_AI_Workshop_Hackathon_Slides_Eunchong_Kang.pptx
+++ b/The_2nd_AI_Workshop_Hackathon_Slides_Eunchong_Kang.pptx
@@ -3339,7 +3339,7 @@
         </p:nvSpPr>
         <p:spPr>
           <a:xfrm>
-            <a:off x="1128748" y="1001623"/>
+            <a:off x="912769" y="1194681"/>
             <a:ext cx="4585335" cy="386117"/>
           </a:xfrm>
           <a:prstGeom prst="rect">
@@ -3361,14 +3361,19 @@
                   <a:srgbClr val="2B5C8A"/>
                 </a:solidFill>
               </a:rPr>
-              <a:t>Goal: Obtain statistical signal of each drug-PT pairs using EBGM</a:t>
-            </a:r>
+              <a:t>Goal: Quantify disproportionality signals for each drug–PT pair using EBGM</a:t>
+            </a:r>
+          </a:p>
+          <a:p>
+            <a:pPr marL="0" indent="0">
+              <a:buNone/>
+            </a:pPr>
             <a:endParaRPr lang="en-US" sz="1500" dirty="0"/>
           </a:p>
         </p:txBody>
       </p:sp>
-      <mc:AlternateContent xmlns:mc="http://schemas.openxmlformats.org/markup-compatibility/2006" xmlns:a14="http://schemas.microsoft.com/office/drawing/2010/main">
-        <mc:Choice Requires="a14">
+      <mc:AlternateContent xmlns:mc="http://schemas.openxmlformats.org/markup-compatibility/2006">
+        <mc:Choice xmlns:a14="http://schemas.microsoft.com/office/drawing/2010/main" Requires="a14">
           <p:sp>
             <p:nvSpPr>
               <p:cNvPr id="5" name="Text 3"/>
@@ -3377,7 +3382,7 @@
             </p:nvSpPr>
             <p:spPr>
               <a:xfrm>
-                <a:off x="1055111" y="3138863"/>
+                <a:off x="1002961" y="3331921"/>
                 <a:ext cx="4937760" cy="1417320"/>
               </a:xfrm>
               <a:prstGeom prst="rect">
@@ -3619,7 +3624,7 @@
             </p:txBody>
           </p:sp>
         </mc:Choice>
-        <mc:Fallback xmlns="">
+        <mc:Fallback>
           <p:sp>
             <p:nvSpPr>
               <p:cNvPr id="5" name="Text 3"/>
@@ -3630,7 +3635,7 @@
             </p:nvSpPr>
             <p:spPr>
               <a:xfrm>
-                <a:off x="1055111" y="3138863"/>
+                <a:off x="1002961" y="3331921"/>
                 <a:ext cx="4937760" cy="1417320"/>
               </a:xfrm>
               <a:prstGeom prst="rect">
@@ -3667,8 +3672,8 @@
         </p:nvSpPr>
         <p:spPr>
           <a:xfrm>
-            <a:off x="6492715" y="1686890"/>
-            <a:ext cx="5303520" cy="411480"/>
+            <a:off x="8255723" y="828522"/>
+            <a:ext cx="1783080" cy="375812"/>
           </a:xfrm>
           <a:prstGeom prst="rect">
             <a:avLst/>
@@ -3714,7 +3719,7 @@
         </p:nvSpPr>
         <p:spPr>
           <a:xfrm>
-            <a:off x="6511003" y="2290394"/>
+            <a:off x="6069604" y="1324894"/>
             <a:ext cx="1783080" cy="310896"/>
           </a:xfrm>
           <a:prstGeom prst="rect">
@@ -3753,7 +3758,7 @@
         </p:nvSpPr>
         <p:spPr>
           <a:xfrm>
-            <a:off x="6511003" y="2647010"/>
+            <a:off x="6069604" y="1681510"/>
             <a:ext cx="1783080" cy="310896"/>
           </a:xfrm>
           <a:prstGeom prst="rect">
@@ -3794,7 +3799,7 @@
         </p:nvSpPr>
         <p:spPr>
           <a:xfrm>
-            <a:off x="8374269" y="2290394"/>
+            <a:off x="7852684" y="1324894"/>
             <a:ext cx="1188720" cy="310896"/>
           </a:xfrm>
           <a:prstGeom prst="rect">
@@ -3833,7 +3838,7 @@
         </p:nvSpPr>
         <p:spPr>
           <a:xfrm>
-            <a:off x="8374269" y="2647010"/>
+            <a:off x="7852684" y="1681510"/>
             <a:ext cx="1188720" cy="310896"/>
           </a:xfrm>
           <a:prstGeom prst="rect">
@@ -3874,7 +3879,7 @@
         </p:nvSpPr>
         <p:spPr>
           <a:xfrm>
-            <a:off x="9738132" y="2290394"/>
+            <a:off x="8831795" y="1324894"/>
             <a:ext cx="1207008" cy="310896"/>
           </a:xfrm>
           <a:prstGeom prst="rect">
@@ -3913,7 +3918,7 @@
         </p:nvSpPr>
         <p:spPr>
           <a:xfrm>
-            <a:off x="9738132" y="2647010"/>
+            <a:off x="8831795" y="1681510"/>
             <a:ext cx="1207008" cy="310896"/>
           </a:xfrm>
           <a:prstGeom prst="rect">
@@ -3954,7 +3959,7 @@
         </p:nvSpPr>
         <p:spPr>
           <a:xfrm>
-            <a:off x="8069352" y="3203808"/>
+            <a:off x="9767899" y="1324894"/>
             <a:ext cx="1828800" cy="310896"/>
           </a:xfrm>
           <a:prstGeom prst="rect">
@@ -3993,7 +3998,7 @@
         </p:nvSpPr>
         <p:spPr>
           <a:xfrm>
-            <a:off x="8069352" y="3560424"/>
+            <a:off x="9767899" y="1681510"/>
             <a:ext cx="1828800" cy="310896"/>
           </a:xfrm>
           <a:prstGeom prst="rect">
@@ -4034,7 +4039,7 @@
         </p:nvSpPr>
         <p:spPr>
           <a:xfrm>
-            <a:off x="868680" y="5112981"/>
+            <a:off x="832460" y="5458613"/>
             <a:ext cx="10561320" cy="676656"/>
           </a:xfrm>
           <a:prstGeom prst="rect">
@@ -4180,8 +4185,38 @@
         </p:blipFill>
         <p:spPr>
           <a:xfrm>
-            <a:off x="2761334" y="1431620"/>
+            <a:off x="2709184" y="1624678"/>
             <a:ext cx="2952750" cy="1333500"/>
+          </a:xfrm>
+          <a:prstGeom prst="rect">
+            <a:avLst/>
+          </a:prstGeom>
+        </p:spPr>
+      </p:pic>
+      <p:pic>
+        <p:nvPicPr>
+          <p:cNvPr id="6" name="Picture 5">
+            <a:extLst>
+              <a:ext uri="{FF2B5EF4-FFF2-40B4-BE49-F238E27FC236}">
+                <a16:creationId xmlns:a16="http://schemas.microsoft.com/office/drawing/2014/main" id="{96F5DFF3-DBE0-87FF-8125-FB58CF456DB2}"/>
+              </a:ext>
+            </a:extLst>
+          </p:cNvPr>
+          <p:cNvPicPr>
+            <a:picLocks noChangeAspect="1"/>
+          </p:cNvPicPr>
+          <p:nvPr/>
+        </p:nvPicPr>
+        <p:blipFill>
+          <a:blip r:embed="rId5"/>
+          <a:stretch>
+            <a:fillRect/>
+          </a:stretch>
+        </p:blipFill>
+        <p:spPr>
+          <a:xfrm>
+            <a:off x="6903272" y="2270077"/>
+            <a:ext cx="3857046" cy="2910864"/>
           </a:xfrm>
           <a:prstGeom prst="rect">
             <a:avLst/>
@@ -4331,7 +4366,7 @@
                 <a:ea typeface="Aptos" pitchFamily="34" charset="-122"/>
                 <a:cs typeface="Aptos" pitchFamily="34" charset="-120"/>
               </a:rPr>
-              <a:t>adverse events, not adverse reactions</a:t>
+              <a:t>adverse events (AE), not adverse reactions (ADR)</a:t>
             </a:r>
             <a:r>
               <a:rPr lang="en-US" sz="1400" dirty="0">
@@ -4362,10 +4397,19 @@
                 <a:ea typeface="Aptos" pitchFamily="34" charset="-122"/>
                 <a:cs typeface="Aptos" pitchFamily="34" charset="-120"/>
               </a:rPr>
-              <a:t>- PTs are classified drug-agnostically into 7 categories using LLM. Then, keep ADR related </a:t>
-            </a:r>
-            <a:r>
-              <a:rPr lang="en-US" sz="1400" dirty="0" err="1">
+              <a:t>- PTs are classified drug-agnostically into 7 categories using LLM. Then, keep PTs that belong to ADR related categories.</a:t>
+            </a:r>
+          </a:p>
+          <a:p>
+            <a:pPr marL="285750" indent="-285750">
+              <a:buFontTx/>
+              <a:buChar char="-"/>
+            </a:pPr>
+            <a:endParaRPr lang="en-US" sz="1400" dirty="0"/>
+          </a:p>
+          <a:p>
+            <a:r>
+              <a:rPr lang="en-US" sz="1400" dirty="0">
                 <a:solidFill>
                   <a:srgbClr val="111111"/>
                 </a:solidFill>
@@ -4373,8 +4417,58 @@
                 <a:ea typeface="Aptos" pitchFamily="34" charset="-122"/>
                 <a:cs typeface="Aptos" pitchFamily="34" charset="-120"/>
               </a:rPr>
-              <a:t>PTs.</a:t>
-            </a:r>
+              <a:t>- Kept categories: </a:t>
+            </a:r>
+            <a:r>
+              <a:rPr lang="en-US" sz="1400" dirty="0">
+                <a:solidFill>
+                  <a:srgbClr val="FF0000"/>
+                </a:solidFill>
+                <a:latin typeface="Aptos" pitchFamily="34" charset="0"/>
+                <a:ea typeface="Aptos" pitchFamily="34" charset="-122"/>
+                <a:cs typeface="Aptos" pitchFamily="34" charset="-120"/>
+              </a:rPr>
+              <a:t>CLINICAL_EVENT </a:t>
+            </a:r>
+            <a:r>
+              <a:rPr lang="en-US" sz="1400" dirty="0">
+                <a:solidFill>
+                  <a:srgbClr val="111111"/>
+                </a:solidFill>
+                <a:latin typeface="Aptos" pitchFamily="34" charset="0"/>
+                <a:ea typeface="Aptos" pitchFamily="34" charset="-122"/>
+                <a:cs typeface="Aptos" pitchFamily="34" charset="-120"/>
+              </a:rPr>
+              <a:t>(e.g. rash) and </a:t>
+            </a:r>
+            <a:r>
+              <a:rPr lang="en-US" sz="1400" dirty="0">
+                <a:solidFill>
+                  <a:srgbClr val="FF0000"/>
+                </a:solidFill>
+                <a:latin typeface="Aptos" pitchFamily="34" charset="0"/>
+                <a:ea typeface="Aptos" pitchFamily="34" charset="-122"/>
+                <a:cs typeface="Aptos" pitchFamily="34" charset="-120"/>
+              </a:rPr>
+              <a:t>LAB_OR_INVESTIGATION </a:t>
+            </a:r>
+            <a:r>
+              <a:rPr lang="en-US" sz="1400" dirty="0">
+                <a:solidFill>
+                  <a:srgbClr val="111111"/>
+                </a:solidFill>
+                <a:latin typeface="Aptos" pitchFamily="34" charset="0"/>
+                <a:ea typeface="Aptos" pitchFamily="34" charset="-122"/>
+                <a:cs typeface="Aptos" pitchFamily="34" charset="-120"/>
+              </a:rPr>
+              <a:t>(blood glucose increased.)</a:t>
+            </a:r>
+          </a:p>
+          <a:p>
+            <a:pPr marL="285750" indent="-285750">
+              <a:buFontTx/>
+              <a:buChar char="-"/>
+            </a:pPr>
             <a:endParaRPr lang="en-US" sz="1400" dirty="0">
               <a:solidFill>
                 <a:srgbClr val="111111"/>
@@ -4385,40 +4479,6 @@
             </a:endParaRPr>
           </a:p>
           <a:p>
-            <a:pPr marL="285750" indent="-285750">
-              <a:buFontTx/>
-              <a:buChar char="-"/>
-            </a:pPr>
-            <a:endParaRPr lang="en-US" sz="1400" dirty="0"/>
-          </a:p>
-          <a:p>
-            <a:r>
-              <a:rPr lang="en-US" sz="1400" dirty="0">
-                <a:solidFill>
-                  <a:srgbClr val="111111"/>
-                </a:solidFill>
-                <a:latin typeface="Aptos" pitchFamily="34" charset="0"/>
-                <a:ea typeface="Aptos" pitchFamily="34" charset="-122"/>
-                <a:cs typeface="Aptos" pitchFamily="34" charset="-120"/>
-              </a:rPr>
-              <a:t>- Kept categories: CLINICAL_EVENT (e.g. rash) and LAB_OR_INVESTIGATION (blood glucose increased.)</a:t>
-            </a:r>
-          </a:p>
-          <a:p>
-            <a:pPr marL="285750" indent="-285750">
-              <a:buFontTx/>
-              <a:buChar char="-"/>
-            </a:pPr>
-            <a:endParaRPr lang="en-US" sz="1400" dirty="0">
-              <a:solidFill>
-                <a:srgbClr val="111111"/>
-              </a:solidFill>
-              <a:latin typeface="Aptos" pitchFamily="34" charset="0"/>
-              <a:ea typeface="Aptos" pitchFamily="34" charset="-122"/>
-              <a:cs typeface="Aptos" pitchFamily="34" charset="-120"/>
-            </a:endParaRPr>
-          </a:p>
-          <a:p>
             <a:r>
               <a:rPr lang="en-US" sz="1400" dirty="0">
                 <a:solidFill>
@@ -4468,7 +4528,7 @@
         </p:spPr>
         <p:txBody>
           <a:bodyPr wrap="square" lIns="137160" tIns="73152" rIns="137160" bIns="73152" rtlCol="0" anchor="ctr">
-            <a:normAutofit lnSpcReduction="10000"/>
+            <a:normAutofit/>
           </a:bodyPr>
           <a:lstStyle/>
           <a:p>
@@ -4533,7 +4593,7 @@
                 <a:ea typeface="Aptos" pitchFamily="34" charset="-122"/>
                 <a:cs typeface="Aptos" pitchFamily="34" charset="-120"/>
               </a:rPr>
-              <a:t>Definitions</a:t>
+              <a:t>Definitions: - Adverse Event (AE): </a:t>
             </a:r>
             <a:r>
               <a:rPr lang="en-US" sz="1130" dirty="0">
@@ -4544,18 +4604,51 @@
                 <a:ea typeface="Aptos" pitchFamily="34" charset="-122"/>
                 <a:cs typeface="Aptos" pitchFamily="34" charset="-120"/>
               </a:rPr>
+              <a:t>any</a:t>
+            </a:r>
+            <a:r>
+              <a:rPr lang="ko-KR" altLang="en-US" sz="1130" dirty="0">
+                <a:solidFill>
+                  <a:srgbClr val="111111"/>
+                </a:solidFill>
+                <a:latin typeface="Aptos" pitchFamily="34" charset="0"/>
+                <a:ea typeface="Aptos" pitchFamily="34" charset="-122"/>
+                <a:cs typeface="Aptos" pitchFamily="34" charset="-120"/>
+              </a:rPr>
               <a:t> </a:t>
             </a:r>
             <a:r>
+              <a:rPr lang="en-US" altLang="ko-KR" sz="1130" dirty="0">
+                <a:solidFill>
+                  <a:srgbClr val="111111"/>
+                </a:solidFill>
+                <a:latin typeface="Aptos" pitchFamily="34" charset="0"/>
+                <a:ea typeface="Aptos" pitchFamily="34" charset="-122"/>
+                <a:cs typeface="Aptos" pitchFamily="34" charset="-120"/>
+              </a:rPr>
+              <a:t>unwanted </a:t>
+            </a:r>
+            <a:r>
               <a:rPr lang="en-US" sz="1130" dirty="0">
                 <a:solidFill>
+                  <a:srgbClr val="111111"/>
+                </a:solidFill>
+                <a:latin typeface="Aptos" pitchFamily="34" charset="0"/>
+                <a:ea typeface="Aptos" pitchFamily="34" charset="-122"/>
+                <a:cs typeface="Aptos" pitchFamily="34" charset="-120"/>
+              </a:rPr>
+              <a:t>… </a:t>
+            </a:r>
+            <a:r>
+              <a:rPr lang="en-US" sz="1130" dirty="0">
+                <a:solidFill>
                   <a:srgbClr val="FF0000"/>
                 </a:solidFill>
                 <a:latin typeface="Aptos" pitchFamily="34" charset="0"/>
                 <a:ea typeface="Aptos" pitchFamily="34" charset="-122"/>
                 <a:cs typeface="Aptos" pitchFamily="34" charset="-120"/>
               </a:rPr>
-              <a:t>(ICH E2A): - Adverse Event (AE): </a:t>
+              <a:t>Background</a:t>
             </a:r>
             <a:r>
               <a:rPr lang="en-US" sz="1130" dirty="0">
@@ -4566,10 +4659,21 @@
                 <a:ea typeface="Aptos" pitchFamily="34" charset="-122"/>
                 <a:cs typeface="Aptos" pitchFamily="34" charset="-120"/>
               </a:rPr>
-              <a:t>any</a:t>
-            </a:r>
-            <a:r>
-              <a:rPr lang="ko-KR" altLang="en-US" sz="1130" dirty="0">
+              <a:t>: I have a list of PTs obtained from FAERS reports … I created the following categories to help determine which PTs could plausibly represent ADRs. Use only these </a:t>
+            </a:r>
+            <a:r>
+              <a:rPr lang="en-US" sz="1130" dirty="0">
+                <a:solidFill>
+                  <a:srgbClr val="FF0000"/>
+                </a:solidFill>
+                <a:latin typeface="Aptos" pitchFamily="34" charset="0"/>
+                <a:ea typeface="Aptos" pitchFamily="34" charset="-122"/>
+                <a:cs typeface="Aptos" pitchFamily="34" charset="-120"/>
+              </a:rPr>
+              <a:t>categories: - CLINICAL_EVENT: </a:t>
+            </a:r>
+            <a:r>
+              <a:rPr lang="en-US" sz="1130" dirty="0">
                 <a:solidFill>
                   <a:srgbClr val="111111"/>
                 </a:solidFill>
@@ -4577,10 +4681,15 @@
                 <a:ea typeface="Aptos" pitchFamily="34" charset="-122"/>
                 <a:cs typeface="Aptos" pitchFamily="34" charset="-120"/>
               </a:rPr>
-              <a:t> </a:t>
-            </a:r>
-            <a:r>
-              <a:rPr lang="en-US" altLang="ko-KR" sz="1130" dirty="0">
+              <a:t>A genuine sign … Goal:</a:t>
+            </a:r>
+          </a:p>
+          <a:p>
+            <a:pPr marL="0" indent="0" algn="l">
+              <a:buNone/>
+            </a:pPr>
+            <a:r>
+              <a:rPr lang="en-US" sz="1130" dirty="0">
                 <a:solidFill>
                   <a:srgbClr val="111111"/>
                 </a:solidFill>
@@ -4588,18 +4697,29 @@
                 <a:ea typeface="Aptos" pitchFamily="34" charset="-122"/>
                 <a:cs typeface="Aptos" pitchFamily="34" charset="-120"/>
               </a:rPr>
-              <a:t>unwanted </a:t>
+              <a:t>Classify each PT into exactly one … </a:t>
             </a:r>
             <a:r>
               <a:rPr lang="en-US" sz="1130" dirty="0">
                 <a:solidFill>
+                  <a:srgbClr val="FF0000"/>
+                </a:solidFill>
+                <a:latin typeface="Aptos" pitchFamily="34" charset="0"/>
+                <a:ea typeface="Aptos" pitchFamily="34" charset="-122"/>
+                <a:cs typeface="Aptos" pitchFamily="34" charset="-120"/>
+              </a:rPr>
+              <a:t>Classification rules</a:t>
+            </a:r>
+            <a:r>
+              <a:rPr lang="en-US" sz="1130" dirty="0">
+                <a:solidFill>
                   <a:srgbClr val="111111"/>
                 </a:solidFill>
                 <a:latin typeface="Aptos" pitchFamily="34" charset="0"/>
                 <a:ea typeface="Aptos" pitchFamily="34" charset="-122"/>
                 <a:cs typeface="Aptos" pitchFamily="34" charset="-120"/>
               </a:rPr>
-              <a:t>… We want to retain only PTs that could plausibly be a genuine adverse reaction to some drug. … </a:t>
+              <a:t>: 1. Make the classification drug-agnostic. </a:t>
             </a:r>
             <a:r>
               <a:rPr lang="en-US" sz="1130" dirty="0">
@@ -4610,7 +4730,7 @@
                 <a:ea typeface="Aptos" pitchFamily="34" charset="-122"/>
                 <a:cs typeface="Aptos" pitchFamily="34" charset="-120"/>
               </a:rPr>
-              <a:t>KEEP PTs </a:t>
+              <a:t>Classify the following 50 PTs: 1. Drug ineffective</a:t>
             </a:r>
             <a:r>
               <a:rPr lang="en-US" sz="1130" dirty="0">
@@ -4621,95 +4741,7 @@
                 <a:ea typeface="Aptos" pitchFamily="34" charset="-122"/>
                 <a:cs typeface="Aptos" pitchFamily="34" charset="-120"/>
               </a:rPr>
-              <a:t>denoting a clinical event/sign/symptom/diagnosis/injury actually experienced by a patient, and lab/investigation findings … </a:t>
-            </a:r>
-            <a:r>
-              <a:rPr lang="en-US" sz="1130" dirty="0">
-                <a:solidFill>
-                  <a:srgbClr val="FF0000"/>
-                </a:solidFill>
-                <a:latin typeface="Aptos" pitchFamily="34" charset="0"/>
-                <a:ea typeface="Aptos" pitchFamily="34" charset="-122"/>
-                <a:cs typeface="Aptos" pitchFamily="34" charset="-120"/>
-              </a:rPr>
-              <a:t>DISCARD PTs </a:t>
-            </a:r>
-            <a:r>
-              <a:rPr lang="en-US" sz="1130" dirty="0">
-                <a:solidFill>
-                  <a:srgbClr val="111111"/>
-                </a:solidFill>
-                <a:latin typeface="Aptos" pitchFamily="34" charset="0"/>
-                <a:ea typeface="Aptos" pitchFamily="34" charset="-122"/>
-                <a:cs typeface="Aptos" pitchFamily="34" charset="-120"/>
-              </a:rPr>
-              <a:t>that are intrinsically NOT a patient clinical event. … </a:t>
-            </a:r>
-            <a:r>
-              <a:rPr lang="en-US" sz="1130" dirty="0">
-                <a:solidFill>
-                  <a:srgbClr val="FF0000"/>
-                </a:solidFill>
-                <a:latin typeface="Aptos" pitchFamily="34" charset="0"/>
-                <a:ea typeface="Aptos" pitchFamily="34" charset="-122"/>
-                <a:cs typeface="Aptos" pitchFamily="34" charset="-120"/>
-              </a:rPr>
-              <a:t>Classify</a:t>
-            </a:r>
-            <a:r>
-              <a:rPr lang="en-US" sz="1130" dirty="0">
-                <a:solidFill>
-                  <a:srgbClr val="111111"/>
-                </a:solidFill>
-                <a:latin typeface="Aptos" pitchFamily="34" charset="0"/>
-                <a:ea typeface="Aptos" pitchFamily="34" charset="-122"/>
-                <a:cs typeface="Aptos" pitchFamily="34" charset="-120"/>
-              </a:rPr>
-              <a:t> each MedDRA Preferred Term (PT) into EXACTLY ONE category below … </a:t>
-            </a:r>
-            <a:r>
-              <a:rPr lang="en-US" sz="1130" dirty="0">
-                <a:solidFill>
-                  <a:srgbClr val="FF0000"/>
-                </a:solidFill>
-                <a:latin typeface="Aptos" pitchFamily="34" charset="0"/>
-                <a:ea typeface="Aptos" pitchFamily="34" charset="-122"/>
-                <a:cs typeface="Aptos" pitchFamily="34" charset="-120"/>
-              </a:rPr>
-              <a:t>CATEGORIES: - CLINICAL_EVENT: </a:t>
-            </a:r>
-            <a:r>
-              <a:rPr lang="en-US" sz="1130" dirty="0">
-                <a:solidFill>
-                  <a:srgbClr val="111111"/>
-                </a:solidFill>
-                <a:latin typeface="Aptos" pitchFamily="34" charset="0"/>
-                <a:ea typeface="Aptos" pitchFamily="34" charset="-122"/>
-                <a:cs typeface="Aptos" pitchFamily="34" charset="-120"/>
-              </a:rPr>
-              <a:t>A genuine clinical sign, … Classify </a:t>
-            </a:r>
-            <a:r>
-              <a:rPr lang="en-US" sz="1130" dirty="0">
-                <a:solidFill>
-                  <a:srgbClr val="FF0000"/>
-                </a:solidFill>
-                <a:latin typeface="Aptos" pitchFamily="34" charset="0"/>
-                <a:ea typeface="Aptos" pitchFamily="34" charset="-122"/>
-                <a:cs typeface="Aptos" pitchFamily="34" charset="-120"/>
-              </a:rPr>
-              <a:t>these 50 PTs</a:t>
-            </a:r>
-            <a:r>
-              <a:rPr lang="en-US" sz="1130" dirty="0">
-                <a:solidFill>
-                  <a:srgbClr val="111111"/>
-                </a:solidFill>
-                <a:latin typeface="Aptos" pitchFamily="34" charset="0"/>
-                <a:ea typeface="Aptos" pitchFamily="34" charset="-122"/>
-                <a:cs typeface="Aptos" pitchFamily="34" charset="-120"/>
-              </a:rPr>
-              <a:t>: 1. Drug ineffective 2. Toxicity to various agents …”</a:t>
+              <a:t> 2. Toxicity to various agents …”</a:t>
             </a:r>
             <a:endParaRPr lang="en-US" sz="1130" dirty="0"/>
           </a:p>
@@ -5134,8 +5166,8 @@
         </p:nvSpPr>
         <p:spPr>
           <a:xfrm>
-            <a:off x="685800" y="1327438"/>
-            <a:ext cx="5577840" cy="219456"/>
+            <a:off x="502920" y="1080893"/>
+            <a:ext cx="4646221" cy="441985"/>
           </a:xfrm>
           <a:prstGeom prst="rect">
             <a:avLst/>
@@ -5156,7 +5188,7 @@
                   <a:srgbClr val="2B5C8A"/>
                 </a:solidFill>
               </a:rPr>
-              <a:t>Question: is the signal already known for this product?</a:t>
+              <a:t>Question: is the signal already known (labeled) for this product?</a:t>
             </a:r>
             <a:endParaRPr lang="en-US" sz="1500" dirty="0"/>
           </a:p>
@@ -5170,7 +5202,7 @@
         </p:nvSpPr>
         <p:spPr>
           <a:xfrm>
-            <a:off x="713232" y="1889140"/>
+            <a:off x="713232" y="1803404"/>
             <a:ext cx="5010912" cy="1844111"/>
           </a:xfrm>
           <a:prstGeom prst="rect">
@@ -5218,7 +5250,7 @@
                 <a:ea typeface="Aptos" pitchFamily="34" charset="-122"/>
                 <a:cs typeface="Aptos" pitchFamily="34" charset="-120"/>
               </a:rPr>
-              <a:t>- Compare candidate AEs against label sections: indications, boxed warning, adverse reactions, warnings/precautions, etc. to categorize each PTs </a:t>
+              <a:t>- Compare candidate AEs against label sections: indications, boxed warning, adverse reactions, etc. to classify each PTs </a:t>
             </a:r>
             <a:r>
               <a:rPr lang="en-US" sz="1310" dirty="0">
@@ -5229,51 +5261,7 @@
                 <a:ea typeface="Aptos" pitchFamily="34" charset="-122"/>
                 <a:cs typeface="Aptos" pitchFamily="34" charset="-120"/>
               </a:rPr>
-              <a:t>into ‘novel’, ‘</a:t>
-            </a:r>
-            <a:r>
-              <a:rPr lang="en-US" sz="1310" dirty="0" err="1">
-                <a:solidFill>
-                  <a:srgbClr val="FF0000"/>
-                </a:solidFill>
-                <a:latin typeface="Aptos" pitchFamily="34" charset="0"/>
-                <a:ea typeface="Aptos" pitchFamily="34" charset="-122"/>
-                <a:cs typeface="Aptos" pitchFamily="34" charset="-120"/>
-              </a:rPr>
-              <a:t>already_labeled</a:t>
-            </a:r>
-            <a:r>
-              <a:rPr lang="en-US" sz="1310" dirty="0">
-                <a:solidFill>
-                  <a:srgbClr val="FF0000"/>
-                </a:solidFill>
-                <a:latin typeface="Aptos" pitchFamily="34" charset="0"/>
-                <a:ea typeface="Aptos" pitchFamily="34" charset="-122"/>
-                <a:cs typeface="Aptos" pitchFamily="34" charset="-120"/>
-              </a:rPr>
-              <a:t>’, and ‘</a:t>
-            </a:r>
-            <a:r>
-              <a:rPr lang="en-US" sz="1310" dirty="0" err="1">
-                <a:solidFill>
-                  <a:srgbClr val="FF0000"/>
-                </a:solidFill>
-                <a:latin typeface="Aptos" pitchFamily="34" charset="0"/>
-                <a:ea typeface="Aptos" pitchFamily="34" charset="-122"/>
-                <a:cs typeface="Aptos" pitchFamily="34" charset="-120"/>
-              </a:rPr>
-              <a:t>disease_related</a:t>
-            </a:r>
-            <a:r>
-              <a:rPr lang="en-US" sz="1310" dirty="0">
-                <a:solidFill>
-                  <a:srgbClr val="FF0000"/>
-                </a:solidFill>
-                <a:latin typeface="Aptos" pitchFamily="34" charset="0"/>
-                <a:ea typeface="Aptos" pitchFamily="34" charset="-122"/>
-                <a:cs typeface="Aptos" pitchFamily="34" charset="-120"/>
-              </a:rPr>
-              <a:t>.’</a:t>
+              <a:t>into ‘NOVEL’, ‘ALREADY_LABELED’, and ‘DISEASE_RELATED.’</a:t>
             </a:r>
           </a:p>
           <a:p>
@@ -5307,7 +5295,19 @@
           <a:p>
             <a:r>
               <a:rPr lang="en-US" sz="1310" dirty="0"/>
-              <a:t>- For the test analysis, I randomly selected 100 drug-brand pairs</a:t>
+              <a:t>- For the test analysis, I randomly selected </a:t>
+            </a:r>
+            <a:r>
+              <a:rPr lang="en-US" sz="1310" dirty="0">
+                <a:solidFill>
+                  <a:srgbClr val="FF0000"/>
+                </a:solidFill>
+              </a:rPr>
+              <a:t>100 drug-brand </a:t>
+            </a:r>
+            <a:r>
+              <a:rPr lang="en-US" sz="1310" dirty="0"/>
+              <a:t>pairs</a:t>
             </a:r>
           </a:p>
         </p:txBody>
@@ -5367,7 +5367,31 @@
             </a:r>
             <a:r>
               <a:rPr lang="en-US" sz="1130" dirty="0"/>
-              <a:t>comparing candidate adverse events (AEs) for ONE drug against that drug's official FDA label. … Treat the ENTIRE label as the source of truth … For each AE, make a </a:t>
+              <a:t>comparing candidate PTs for one drug against that drug's official FDA label. … </a:t>
+            </a:r>
+            <a:r>
+              <a:rPr lang="en-US" sz="1130" dirty="0">
+                <a:solidFill>
+                  <a:srgbClr val="FF0000"/>
+                </a:solidFill>
+              </a:rPr>
+              <a:t>Background</a:t>
+            </a:r>
+            <a:r>
+              <a:rPr lang="en-US" sz="1130" dirty="0"/>
+              <a:t>: The label text is provided as reference material … Treat the ENTIRE label as the source of truth … </a:t>
+            </a:r>
+            <a:r>
+              <a:rPr lang="en-US" sz="1130" dirty="0">
+                <a:solidFill>
+                  <a:srgbClr val="FF0000"/>
+                </a:solidFill>
+              </a:rPr>
+              <a:t>Classification rules</a:t>
+            </a:r>
+            <a:r>
+              <a:rPr lang="en-US" sz="1130" dirty="0"/>
+              <a:t>: For each candidate PT, make a </a:t>
             </a:r>
             <a:r>
               <a:rPr lang="en-US" sz="1130" dirty="0">
@@ -5387,11 +5411,11 @@
                   <a:srgbClr val="FF0000"/>
                 </a:solidFill>
               </a:rPr>
-              <a:t>1.</a:t>
+              <a:t>1. If </a:t>
             </a:r>
             <a:r>
               <a:rPr lang="en-US" sz="1130" dirty="0"/>
-              <a:t> If the AE is really the drug's INDICATION … </a:t>
+              <a:t>the AE is really the drug's INDICATION … </a:t>
             </a:r>
             <a:r>
               <a:rPr lang="en-US" sz="1130" dirty="0">
@@ -5399,11 +5423,11 @@
                   <a:srgbClr val="FF0000"/>
                 </a:solidFill>
               </a:rPr>
-              <a:t>2.</a:t>
+              <a:t>2. Else if </a:t>
             </a:r>
             <a:r>
               <a:rPr lang="en-US" sz="1130" dirty="0"/>
-              <a:t> Else if the label describes the AE as something the drug can cause … </a:t>
+              <a:t>the label describes the AE as something the drug can cause … </a:t>
             </a:r>
             <a:r>
               <a:rPr lang="en-US" sz="1130" dirty="0">
@@ -5411,11 +5435,11 @@
                   <a:srgbClr val="FF0000"/>
                 </a:solidFill>
               </a:rPr>
-              <a:t>3.</a:t>
+              <a:t>3. Else </a:t>
             </a:r>
             <a:r>
               <a:rPr lang="en-US" sz="1130" dirty="0"/>
-              <a:t> Else -&gt; novel (a potential unlabeled ADR) … === </a:t>
+              <a:t>-&gt; novel (a potential unlabeled ADR) … === </a:t>
             </a:r>
             <a:r>
               <a:rPr lang="en-US" sz="1130" dirty="0">
@@ -5722,7 +5746,7 @@
         </p:blipFill>
         <p:spPr>
           <a:xfrm>
-            <a:off x="5806440" y="1327438"/>
+            <a:off x="5928360" y="1437166"/>
             <a:ext cx="5843847" cy="2267688"/>
           </a:xfrm>
           <a:prstGeom prst="rect">
@@ -7165,7 +7189,7 @@
                 <a:ea typeface="Aptos" pitchFamily="34" charset="-122"/>
                 <a:cs typeface="Aptos" pitchFamily="34" charset="-120"/>
               </a:rPr>
-              <a:t>Validation summary: 93 drugs evaluated. Median lift@10 was 1.30 for the five-component score vs 1.01 for EB05 alone; lift &gt; 1 in 77% vs 51% of drugs.</a:t>
+              <a:t>Validation summary: 93 drugs evaluated. Median lift@10 was 1.32 for the five-component score vs 1.00 for EB05 alone; lift &gt; 1 in 78% vs 46% of drugs.</a:t>
             </a:r>
             <a:endParaRPr lang="en-US" sz="1330" dirty="0"/>
           </a:p>
@@ -7521,7 +7545,7 @@
                 <a:ea typeface="Aptos" pitchFamily="34" charset="-122"/>
                 <a:cs typeface="Aptos" pitchFamily="34" charset="-120"/>
               </a:rPr>
-              <a:t>- Built an automatic, LLM-assisted pipeline from raw FAERS reports to ranked candidates for potentially unlabeled ADRs.</a:t>
+              <a:t>- Built an automatic, LLM-assisted pipeline from FAERS reports to ranked candidates for potentially unlabeled ADRs.</a:t>
             </a:r>
           </a:p>
           <a:p>

</xml_diff>